<commit_message>
final version of the files
</commit_message>
<xml_diff>
--- a/docs/Assessment2.pptx
+++ b/docs/Assessment2.pptx
@@ -272,7 +272,7 @@
           <a:p>
             <a:fld id="{542CA1D3-40D2-8347-B575-DC041F38E38E}" type="datetimeFigureOut">
               <a:rPr lang="en-US" smtClean="0"/>
-              <a:t>9/24/26</a:t>
+              <a:t>9/26/26</a:t>
             </a:fld>
             <a:endParaRPr lang="en-US"/>
           </a:p>
@@ -472,7 +472,7 @@
           <a:p>
             <a:fld id="{542CA1D3-40D2-8347-B575-DC041F38E38E}" type="datetimeFigureOut">
               <a:rPr lang="en-US" smtClean="0"/>
-              <a:t>9/24/26</a:t>
+              <a:t>9/26/26</a:t>
             </a:fld>
             <a:endParaRPr lang="en-US"/>
           </a:p>
@@ -682,7 +682,7 @@
           <a:p>
             <a:fld id="{542CA1D3-40D2-8347-B575-DC041F38E38E}" type="datetimeFigureOut">
               <a:rPr lang="en-US" smtClean="0"/>
-              <a:t>9/24/26</a:t>
+              <a:t>9/26/26</a:t>
             </a:fld>
             <a:endParaRPr lang="en-US"/>
           </a:p>
@@ -882,7 +882,7 @@
           <a:p>
             <a:fld id="{542CA1D3-40D2-8347-B575-DC041F38E38E}" type="datetimeFigureOut">
               <a:rPr lang="en-US" smtClean="0"/>
-              <a:t>9/24/26</a:t>
+              <a:t>9/26/26</a:t>
             </a:fld>
             <a:endParaRPr lang="en-US"/>
           </a:p>
@@ -1158,7 +1158,7 @@
           <a:p>
             <a:fld id="{542CA1D3-40D2-8347-B575-DC041F38E38E}" type="datetimeFigureOut">
               <a:rPr lang="en-US" smtClean="0"/>
-              <a:t>9/24/26</a:t>
+              <a:t>9/26/26</a:t>
             </a:fld>
             <a:endParaRPr lang="en-US"/>
           </a:p>
@@ -1426,7 +1426,7 @@
           <a:p>
             <a:fld id="{542CA1D3-40D2-8347-B575-DC041F38E38E}" type="datetimeFigureOut">
               <a:rPr lang="en-US" smtClean="0"/>
-              <a:t>9/24/26</a:t>
+              <a:t>9/26/26</a:t>
             </a:fld>
             <a:endParaRPr lang="en-US"/>
           </a:p>
@@ -1841,7 +1841,7 @@
           <a:p>
             <a:fld id="{542CA1D3-40D2-8347-B575-DC041F38E38E}" type="datetimeFigureOut">
               <a:rPr lang="en-US" smtClean="0"/>
-              <a:t>9/24/26</a:t>
+              <a:t>9/26/26</a:t>
             </a:fld>
             <a:endParaRPr lang="en-US"/>
           </a:p>
@@ -1983,7 +1983,7 @@
           <a:p>
             <a:fld id="{542CA1D3-40D2-8347-B575-DC041F38E38E}" type="datetimeFigureOut">
               <a:rPr lang="en-US" smtClean="0"/>
-              <a:t>9/24/26</a:t>
+              <a:t>9/26/26</a:t>
             </a:fld>
             <a:endParaRPr lang="en-US"/>
           </a:p>
@@ -2096,7 +2096,7 @@
           <a:p>
             <a:fld id="{542CA1D3-40D2-8347-B575-DC041F38E38E}" type="datetimeFigureOut">
               <a:rPr lang="en-US" smtClean="0"/>
-              <a:t>9/24/26</a:t>
+              <a:t>9/26/26</a:t>
             </a:fld>
             <a:endParaRPr lang="en-US"/>
           </a:p>
@@ -2409,7 +2409,7 @@
           <a:p>
             <a:fld id="{542CA1D3-40D2-8347-B575-DC041F38E38E}" type="datetimeFigureOut">
               <a:rPr lang="en-US" smtClean="0"/>
-              <a:t>9/24/26</a:t>
+              <a:t>9/26/26</a:t>
             </a:fld>
             <a:endParaRPr lang="en-US"/>
           </a:p>
@@ -2698,7 +2698,7 @@
           <a:p>
             <a:fld id="{542CA1D3-40D2-8347-B575-DC041F38E38E}" type="datetimeFigureOut">
               <a:rPr lang="en-US" smtClean="0"/>
-              <a:t>9/24/26</a:t>
+              <a:t>9/26/26</a:t>
             </a:fld>
             <a:endParaRPr lang="en-US"/>
           </a:p>
@@ -2941,7 +2941,7 @@
           <a:p>
             <a:fld id="{542CA1D3-40D2-8347-B575-DC041F38E38E}" type="datetimeFigureOut">
               <a:rPr lang="en-US" smtClean="0"/>
-              <a:t>9/24/26</a:t>
+              <a:t>9/26/26</a:t>
             </a:fld>
             <a:endParaRPr lang="en-US"/>
           </a:p>
@@ -5374,89 +5374,6 @@
       </p:sp>
       <p:sp>
         <p:nvSpPr>
-          <p:cNvPr id="14" name="Rectangle 13"/>
-          <p:cNvSpPr/>
-          <p:nvPr/>
-        </p:nvSpPr>
-        <p:spPr>
-          <a:xfrm>
-            <a:off x="9491472" y="4846320"/>
-            <a:ext cx="2103120" cy="1444752"/>
-          </a:xfrm>
-          <a:prstGeom prst="rect">
-            <a:avLst/>
-          </a:prstGeom>
-          <a:noFill/>
-          <a:ln>
-            <a:solidFill>
-              <a:srgbClr val="D6DADF"/>
-            </a:solidFill>
-          </a:ln>
-        </p:spPr>
-        <p:style>
-          <a:lnRef idx="1">
-            <a:schemeClr val="accent1"/>
-          </a:lnRef>
-          <a:fillRef idx="3">
-            <a:schemeClr val="accent1"/>
-          </a:fillRef>
-          <a:effectRef idx="2">
-            <a:schemeClr val="accent1"/>
-          </a:effectRef>
-          <a:fontRef idx="minor">
-            <a:schemeClr val="lt1"/>
-          </a:fontRef>
-        </p:style>
-        <p:txBody>
-          <a:bodyPr rtlCol="0" anchor="ctr"/>
-          <a:lstStyle/>
-          <a:p>
-            <a:pPr algn="ctr"/>
-            <a:endParaRPr/>
-          </a:p>
-        </p:txBody>
-      </p:sp>
-      <p:sp>
-        <p:nvSpPr>
-          <p:cNvPr id="15" name="TextBox 14"/>
-          <p:cNvSpPr txBox="1"/>
-          <p:nvPr/>
-        </p:nvSpPr>
-        <p:spPr>
-          <a:xfrm>
-            <a:off x="9692640" y="5266944"/>
-            <a:ext cx="1700784" cy="438912"/>
-          </a:xfrm>
-          <a:prstGeom prst="rect">
-            <a:avLst/>
-          </a:prstGeom>
-          <a:noFill/>
-        </p:spPr>
-        <p:txBody>
-          <a:bodyPr wrap="square" anchor="ctr">
-            <a:spAutoFit/>
-          </a:bodyPr>
-          <a:lstStyle/>
-          <a:p>
-            <a:pPr algn="ctr"/>
-            <a:r>
-              <a:rPr sz="1000" b="0">
-                <a:solidFill>
-                  <a:srgbClr val="676D75"/>
-                </a:solidFill>
-                <a:latin typeface="Arial"/>
-              </a:rPr>
-              <a:t>Reserved for</a:t>
-            </a:r>
-            <a:br/>
-            <a:r>
-              <a:t>speaker video</a:t>
-            </a:r>
-          </a:p>
-        </p:txBody>
-      </p:sp>
-      <p:sp>
-        <p:nvSpPr>
           <p:cNvPr id="16" name="Rounded Rectangle 15"/>
           <p:cNvSpPr/>
           <p:nvPr/>
@@ -6777,91 +6694,6 @@
       </p:sp>
       <p:sp>
         <p:nvSpPr>
-          <p:cNvPr id="33" name="Rounded Rectangle 32"/>
-          <p:cNvSpPr/>
-          <p:nvPr/>
-        </p:nvSpPr>
-        <p:spPr>
-          <a:xfrm>
-            <a:off x="9555480" y="4434840"/>
-            <a:ext cx="2148840" cy="1874519"/>
-          </a:xfrm>
-          <a:prstGeom prst="roundRect">
-            <a:avLst/>
-          </a:prstGeom>
-          <a:solidFill>
-            <a:srgbClr val="F7F9FC"/>
-          </a:solidFill>
-          <a:ln>
-            <a:solidFill>
-              <a:srgbClr val="D8E0E8"/>
-            </a:solidFill>
-          </a:ln>
-        </p:spPr>
-        <p:style>
-          <a:lnRef idx="1">
-            <a:schemeClr val="accent1"/>
-          </a:lnRef>
-          <a:fillRef idx="3">
-            <a:schemeClr val="accent1"/>
-          </a:fillRef>
-          <a:effectRef idx="2">
-            <a:schemeClr val="accent1"/>
-          </a:effectRef>
-          <a:fontRef idx="minor">
-            <a:schemeClr val="lt1"/>
-          </a:fontRef>
-        </p:style>
-        <p:txBody>
-          <a:bodyPr rtlCol="0" anchor="ctr"/>
-          <a:lstStyle/>
-          <a:p>
-            <a:pPr algn="ctr"/>
-            <a:endParaRPr/>
-          </a:p>
-        </p:txBody>
-      </p:sp>
-      <p:sp>
-        <p:nvSpPr>
-          <p:cNvPr id="34" name="TextBox 33"/>
-          <p:cNvSpPr txBox="1"/>
-          <p:nvPr/>
-        </p:nvSpPr>
-        <p:spPr>
-          <a:xfrm>
-            <a:off x="9765792" y="5010912"/>
-            <a:ext cx="1737360" cy="502920"/>
-          </a:xfrm>
-          <a:prstGeom prst="rect">
-            <a:avLst/>
-          </a:prstGeom>
-          <a:noFill/>
-        </p:spPr>
-        <p:txBody>
-          <a:bodyPr wrap="square" anchor="ctr">
-            <a:spAutoFit/>
-          </a:bodyPr>
-          <a:lstStyle/>
-          <a:p>
-            <a:pPr algn="ctr"/>
-            <a:r>
-              <a:rPr sz="1019" b="0">
-                <a:solidFill>
-                  <a:srgbClr val="68707A"/>
-                </a:solidFill>
-                <a:latin typeface="Arial"/>
-              </a:rPr>
-              <a:t>Reserved for</a:t>
-            </a:r>
-            <a:br/>
-            <a:r>
-              <a:t>speaker video</a:t>
-            </a:r>
-          </a:p>
-        </p:txBody>
-      </p:sp>
-      <p:sp>
-        <p:nvSpPr>
           <p:cNvPr id="35" name="TextBox 34"/>
           <p:cNvSpPr txBox="1"/>
           <p:nvPr/>
@@ -8072,13 +7904,13 @@
       </p:sp>
       <p:sp>
         <p:nvSpPr>
-          <p:cNvPr id="33" name="TextBox 32"/>
-          <p:cNvSpPr txBox="1"/>
-          <p:nvPr/>
-        </p:nvSpPr>
-        <p:spPr>
-          <a:xfrm>
-            <a:off x="6684264" y="3694176"/>
+          <p:cNvPr id="35" name="TextBox 34"/>
+          <p:cNvSpPr txBox="1"/>
+          <p:nvPr/>
+        </p:nvSpPr>
+        <p:spPr>
+          <a:xfrm>
+            <a:off x="6684264" y="3795186"/>
             <a:ext cx="2084832" cy="246888"/>
           </a:xfrm>
           <a:prstGeom prst="rect">
@@ -8100,76 +7932,6 @@
                 </a:solidFill>
                 <a:latin typeface="Arial"/>
               </a:rPr>
-              <a:t>Verified roles</a:t>
-            </a:r>
-          </a:p>
-        </p:txBody>
-      </p:sp>
-      <p:sp>
-        <p:nvSpPr>
-          <p:cNvPr id="34" name="TextBox 33"/>
-          <p:cNvSpPr txBox="1"/>
-          <p:nvPr/>
-        </p:nvSpPr>
-        <p:spPr>
-          <a:xfrm>
-            <a:off x="6684264" y="3941064"/>
-            <a:ext cx="2084832" cy="502920"/>
-          </a:xfrm>
-          <a:prstGeom prst="rect">
-            <a:avLst/>
-          </a:prstGeom>
-          <a:noFill/>
-        </p:spPr>
-        <p:txBody>
-          <a:bodyPr wrap="square" anchor="ctr">
-            <a:spAutoFit/>
-          </a:bodyPr>
-          <a:lstStyle/>
-          <a:p>
-            <a:pPr algn="l"/>
-            <a:r>
-              <a:rPr sz="950" b="0">
-                <a:solidFill>
-                  <a:srgbClr val="676D75"/>
-                </a:solidFill>
-                <a:latin typeface="Arial"/>
-              </a:rPr>
-              <a:t>Each member states a specific contribution in the video / GROUP_INFO.</a:t>
-            </a:r>
-          </a:p>
-        </p:txBody>
-      </p:sp>
-      <p:sp>
-        <p:nvSpPr>
-          <p:cNvPr id="35" name="TextBox 34"/>
-          <p:cNvSpPr txBox="1"/>
-          <p:nvPr/>
-        </p:nvSpPr>
-        <p:spPr>
-          <a:xfrm>
-            <a:off x="6684264" y="4535424"/>
-            <a:ext cx="2084832" cy="246888"/>
-          </a:xfrm>
-          <a:prstGeom prst="rect">
-            <a:avLst/>
-          </a:prstGeom>
-          <a:noFill/>
-        </p:spPr>
-        <p:txBody>
-          <a:bodyPr wrap="square" anchor="ctr">
-            <a:spAutoFit/>
-          </a:bodyPr>
-          <a:lstStyle/>
-          <a:p>
-            <a:pPr algn="l"/>
-            <a:r>
-              <a:rPr sz="1080" b="1">
-                <a:solidFill>
-                  <a:srgbClr val="0B2E59"/>
-                </a:solidFill>
-                <a:latin typeface="Arial"/>
-              </a:rPr>
               <a:t>Final review</a:t>
             </a:r>
           </a:p>
@@ -8183,7 +7945,7 @@
         </p:nvSpPr>
         <p:spPr>
           <a:xfrm>
-            <a:off x="6684264" y="4782312"/>
+            <a:off x="6684264" y="4042074"/>
             <a:ext cx="2084832" cy="502920"/>
           </a:xfrm>
           <a:prstGeom prst="rect">
@@ -8328,91 +8090,6 @@
       </p:sp>
       <p:sp>
         <p:nvSpPr>
-          <p:cNvPr id="40" name="Rounded Rectangle 39"/>
-          <p:cNvSpPr/>
-          <p:nvPr/>
-        </p:nvSpPr>
-        <p:spPr>
-          <a:xfrm>
-            <a:off x="9555480" y="4434840"/>
-            <a:ext cx="2148840" cy="1874519"/>
-          </a:xfrm>
-          <a:prstGeom prst="roundRect">
-            <a:avLst/>
-          </a:prstGeom>
-          <a:solidFill>
-            <a:srgbClr val="F7F9FC"/>
-          </a:solidFill>
-          <a:ln>
-            <a:solidFill>
-              <a:srgbClr val="D8E0E8"/>
-            </a:solidFill>
-          </a:ln>
-        </p:spPr>
-        <p:style>
-          <a:lnRef idx="1">
-            <a:schemeClr val="accent1"/>
-          </a:lnRef>
-          <a:fillRef idx="3">
-            <a:schemeClr val="accent1"/>
-          </a:fillRef>
-          <a:effectRef idx="2">
-            <a:schemeClr val="accent1"/>
-          </a:effectRef>
-          <a:fontRef idx="minor">
-            <a:schemeClr val="lt1"/>
-          </a:fontRef>
-        </p:style>
-        <p:txBody>
-          <a:bodyPr rtlCol="0" anchor="ctr"/>
-          <a:lstStyle/>
-          <a:p>
-            <a:pPr algn="ctr"/>
-            <a:endParaRPr/>
-          </a:p>
-        </p:txBody>
-      </p:sp>
-      <p:sp>
-        <p:nvSpPr>
-          <p:cNvPr id="41" name="TextBox 40"/>
-          <p:cNvSpPr txBox="1"/>
-          <p:nvPr/>
-        </p:nvSpPr>
-        <p:spPr>
-          <a:xfrm>
-            <a:off x="9765792" y="5010912"/>
-            <a:ext cx="1737360" cy="502920"/>
-          </a:xfrm>
-          <a:prstGeom prst="rect">
-            <a:avLst/>
-          </a:prstGeom>
-          <a:noFill/>
-        </p:spPr>
-        <p:txBody>
-          <a:bodyPr wrap="square" anchor="ctr">
-            <a:spAutoFit/>
-          </a:bodyPr>
-          <a:lstStyle/>
-          <a:p>
-            <a:pPr algn="ctr"/>
-            <a:r>
-              <a:rPr sz="1019" b="0">
-                <a:solidFill>
-                  <a:srgbClr val="676D75"/>
-                </a:solidFill>
-                <a:latin typeface="Arial"/>
-              </a:rPr>
-              <a:t>Reserved for</a:t>
-            </a:r>
-            <a:br/>
-            <a:r>
-              <a:t>speaker video</a:t>
-            </a:r>
-          </a:p>
-        </p:txBody>
-      </p:sp>
-      <p:sp>
-        <p:nvSpPr>
           <p:cNvPr id="42" name="Rounded Rectangle 41"/>
           <p:cNvSpPr/>
           <p:nvPr/>
@@ -8420,7 +8097,7 @@
         <p:spPr>
           <a:xfrm>
             <a:off x="9281160" y="1325880"/>
-            <a:ext cx="2724374" cy="2368296"/>
+            <a:ext cx="2724374" cy="4297680"/>
           </a:xfrm>
           <a:prstGeom prst="roundRect">
             <a:avLst/>
@@ -9776,90 +9453,6 @@
           </a:p>
         </p:txBody>
       </p:sp>
-      <p:sp>
-        <p:nvSpPr>
-          <p:cNvPr id="31" name="Rectangle 30"/>
-          <p:cNvSpPr/>
-          <p:nvPr/>
-        </p:nvSpPr>
-        <p:spPr>
-          <a:xfrm>
-            <a:off x="9189720" y="4315968"/>
-            <a:ext cx="2423160" cy="2057400"/>
-          </a:xfrm>
-          <a:prstGeom prst="rect">
-            <a:avLst/>
-          </a:prstGeom>
-          <a:noFill/>
-          <a:ln>
-            <a:solidFill>
-              <a:srgbClr val="D0D4DA"/>
-            </a:solidFill>
-            <a:prstDash val="dash"/>
-          </a:ln>
-        </p:spPr>
-        <p:style>
-          <a:lnRef idx="1">
-            <a:schemeClr val="accent1"/>
-          </a:lnRef>
-          <a:fillRef idx="3">
-            <a:schemeClr val="accent1"/>
-          </a:fillRef>
-          <a:effectRef idx="2">
-            <a:schemeClr val="accent1"/>
-          </a:effectRef>
-          <a:fontRef idx="minor">
-            <a:schemeClr val="lt1"/>
-          </a:fontRef>
-        </p:style>
-        <p:txBody>
-          <a:bodyPr rtlCol="0" anchor="ctr"/>
-          <a:lstStyle/>
-          <a:p>
-            <a:pPr algn="ctr"/>
-            <a:endParaRPr/>
-          </a:p>
-        </p:txBody>
-      </p:sp>
-      <p:sp>
-        <p:nvSpPr>
-          <p:cNvPr id="32" name="TextBox 31"/>
-          <p:cNvSpPr txBox="1"/>
-          <p:nvPr/>
-        </p:nvSpPr>
-        <p:spPr>
-          <a:xfrm>
-            <a:off x="9418320" y="5010912"/>
-            <a:ext cx="1965960" cy="457200"/>
-          </a:xfrm>
-          <a:prstGeom prst="rect">
-            <a:avLst/>
-          </a:prstGeom>
-          <a:noFill/>
-        </p:spPr>
-        <p:txBody>
-          <a:bodyPr wrap="square" anchor="ctr">
-            <a:spAutoFit/>
-          </a:bodyPr>
-          <a:lstStyle/>
-          <a:p>
-            <a:pPr algn="ctr"/>
-            <a:r>
-              <a:rPr sz="1050" b="0">
-                <a:solidFill>
-                  <a:srgbClr val="6B7280"/>
-                </a:solidFill>
-                <a:latin typeface="Arial"/>
-              </a:rPr>
-              <a:t>Reserved for</a:t>
-            </a:r>
-            <a:br/>
-            <a:r>
-              <a:t>speaker video</a:t>
-            </a:r>
-          </a:p>
-        </p:txBody>
-      </p:sp>
     </p:spTree>
     <p:extLst>
       <p:ext uri="{BB962C8B-B14F-4D97-AF65-F5344CB8AC3E}">
@@ -11151,90 +10744,6 @@
           </a:p>
         </p:txBody>
       </p:sp>
-      <p:sp>
-        <p:nvSpPr>
-          <p:cNvPr id="33" name="Rectangle 32"/>
-          <p:cNvSpPr/>
-          <p:nvPr/>
-        </p:nvSpPr>
-        <p:spPr>
-          <a:xfrm>
-            <a:off x="9098281" y="4882897"/>
-            <a:ext cx="2756646" cy="1837942"/>
-          </a:xfrm>
-          <a:prstGeom prst="rect">
-            <a:avLst/>
-          </a:prstGeom>
-          <a:noFill/>
-          <a:ln>
-            <a:solidFill>
-              <a:srgbClr val="D0D4DA"/>
-            </a:solidFill>
-            <a:prstDash val="dash"/>
-          </a:ln>
-        </p:spPr>
-        <p:style>
-          <a:lnRef idx="1">
-            <a:schemeClr val="accent1"/>
-          </a:lnRef>
-          <a:fillRef idx="3">
-            <a:schemeClr val="accent1"/>
-          </a:fillRef>
-          <a:effectRef idx="2">
-            <a:schemeClr val="accent1"/>
-          </a:effectRef>
-          <a:fontRef idx="minor">
-            <a:schemeClr val="lt1"/>
-          </a:fontRef>
-        </p:style>
-        <p:txBody>
-          <a:bodyPr rtlCol="0" anchor="ctr"/>
-          <a:lstStyle/>
-          <a:p>
-            <a:pPr algn="ctr"/>
-            <a:endParaRPr/>
-          </a:p>
-        </p:txBody>
-      </p:sp>
-      <p:sp>
-        <p:nvSpPr>
-          <p:cNvPr id="34" name="TextBox 33"/>
-          <p:cNvSpPr txBox="1"/>
-          <p:nvPr/>
-        </p:nvSpPr>
-        <p:spPr>
-          <a:xfrm>
-            <a:off x="9418320" y="5404104"/>
-            <a:ext cx="1965960" cy="438912"/>
-          </a:xfrm>
-          <a:prstGeom prst="rect">
-            <a:avLst/>
-          </a:prstGeom>
-          <a:noFill/>
-        </p:spPr>
-        <p:txBody>
-          <a:bodyPr wrap="square" anchor="ctr">
-            <a:spAutoFit/>
-          </a:bodyPr>
-          <a:lstStyle/>
-          <a:p>
-            <a:pPr algn="ctr"/>
-            <a:r>
-              <a:rPr sz="1050" b="0">
-                <a:solidFill>
-                  <a:srgbClr val="6B7280"/>
-                </a:solidFill>
-                <a:latin typeface="Arial"/>
-              </a:rPr>
-              <a:t>Reserved for</a:t>
-            </a:r>
-            <a:br/>
-            <a:r>
-              <a:t>speaker video</a:t>
-            </a:r>
-          </a:p>
-        </p:txBody>
-      </p:sp>
     </p:spTree>
     <p:extLst>
       <p:ext uri="{BB962C8B-B14F-4D97-AF65-F5344CB8AC3E}">
@@ -11741,90 +11250,6 @@
           </a:p>
         </p:txBody>
       </p:sp>
-      <p:sp>
-        <p:nvSpPr>
-          <p:cNvPr id="14" name="Rectangle 13"/>
-          <p:cNvSpPr/>
-          <p:nvPr/>
-        </p:nvSpPr>
-        <p:spPr>
-          <a:xfrm>
-            <a:off x="9217152" y="5065776"/>
-            <a:ext cx="2377440" cy="1298448"/>
-          </a:xfrm>
-          <a:prstGeom prst="rect">
-            <a:avLst/>
-          </a:prstGeom>
-          <a:noFill/>
-          <a:ln>
-            <a:solidFill>
-              <a:srgbClr val="D0D4DA"/>
-            </a:solidFill>
-            <a:prstDash val="dash"/>
-          </a:ln>
-        </p:spPr>
-        <p:style>
-          <a:lnRef idx="1">
-            <a:schemeClr val="accent1"/>
-          </a:lnRef>
-          <a:fillRef idx="3">
-            <a:schemeClr val="accent1"/>
-          </a:fillRef>
-          <a:effectRef idx="2">
-            <a:schemeClr val="accent1"/>
-          </a:effectRef>
-          <a:fontRef idx="minor">
-            <a:schemeClr val="lt1"/>
-          </a:fontRef>
-        </p:style>
-        <p:txBody>
-          <a:bodyPr rtlCol="0" anchor="ctr"/>
-          <a:lstStyle/>
-          <a:p>
-            <a:pPr algn="ctr"/>
-            <a:endParaRPr/>
-          </a:p>
-        </p:txBody>
-      </p:sp>
-      <p:sp>
-        <p:nvSpPr>
-          <p:cNvPr id="15" name="TextBox 14"/>
-          <p:cNvSpPr txBox="1"/>
-          <p:nvPr/>
-        </p:nvSpPr>
-        <p:spPr>
-          <a:xfrm>
-            <a:off x="9418320" y="5394960"/>
-            <a:ext cx="1965960" cy="438912"/>
-          </a:xfrm>
-          <a:prstGeom prst="rect">
-            <a:avLst/>
-          </a:prstGeom>
-          <a:noFill/>
-        </p:spPr>
-        <p:txBody>
-          <a:bodyPr wrap="square" anchor="ctr">
-            <a:spAutoFit/>
-          </a:bodyPr>
-          <a:lstStyle/>
-          <a:p>
-            <a:pPr algn="ctr"/>
-            <a:r>
-              <a:rPr sz="1050" b="0">
-                <a:solidFill>
-                  <a:srgbClr val="6B7280"/>
-                </a:solidFill>
-                <a:latin typeface="Arial"/>
-              </a:rPr>
-              <a:t>Reserved for</a:t>
-            </a:r>
-            <a:br/>
-            <a:r>
-              <a:t>speaker video</a:t>
-            </a:r>
-          </a:p>
-        </p:txBody>
-      </p:sp>
     </p:spTree>
     <p:extLst>
       <p:ext uri="{BB962C8B-B14F-4D97-AF65-F5344CB8AC3E}">
@@ -12274,90 +11699,6 @@
           </a:p>
         </p:txBody>
       </p:sp>
-      <p:sp>
-        <p:nvSpPr>
-          <p:cNvPr id="13" name="Rectangle 12"/>
-          <p:cNvSpPr/>
-          <p:nvPr/>
-        </p:nvSpPr>
-        <p:spPr>
-          <a:xfrm>
-            <a:off x="9217152" y="5065776"/>
-            <a:ext cx="2377440" cy="1298448"/>
-          </a:xfrm>
-          <a:prstGeom prst="rect">
-            <a:avLst/>
-          </a:prstGeom>
-          <a:noFill/>
-          <a:ln>
-            <a:solidFill>
-              <a:srgbClr val="D0D4DA"/>
-            </a:solidFill>
-            <a:prstDash val="dash"/>
-          </a:ln>
-        </p:spPr>
-        <p:style>
-          <a:lnRef idx="1">
-            <a:schemeClr val="accent1"/>
-          </a:lnRef>
-          <a:fillRef idx="3">
-            <a:schemeClr val="accent1"/>
-          </a:fillRef>
-          <a:effectRef idx="2">
-            <a:schemeClr val="accent1"/>
-          </a:effectRef>
-          <a:fontRef idx="minor">
-            <a:schemeClr val="lt1"/>
-          </a:fontRef>
-        </p:style>
-        <p:txBody>
-          <a:bodyPr rtlCol="0" anchor="ctr"/>
-          <a:lstStyle/>
-          <a:p>
-            <a:pPr algn="ctr"/>
-            <a:endParaRPr/>
-          </a:p>
-        </p:txBody>
-      </p:sp>
-      <p:sp>
-        <p:nvSpPr>
-          <p:cNvPr id="14" name="TextBox 13"/>
-          <p:cNvSpPr txBox="1"/>
-          <p:nvPr/>
-        </p:nvSpPr>
-        <p:spPr>
-          <a:xfrm>
-            <a:off x="9418320" y="5394960"/>
-            <a:ext cx="1965960" cy="438912"/>
-          </a:xfrm>
-          <a:prstGeom prst="rect">
-            <a:avLst/>
-          </a:prstGeom>
-          <a:noFill/>
-        </p:spPr>
-        <p:txBody>
-          <a:bodyPr wrap="square" anchor="ctr">
-            <a:spAutoFit/>
-          </a:bodyPr>
-          <a:lstStyle/>
-          <a:p>
-            <a:pPr algn="ctr"/>
-            <a:r>
-              <a:rPr sz="1050" b="0">
-                <a:solidFill>
-                  <a:srgbClr val="6B7280"/>
-                </a:solidFill>
-                <a:latin typeface="Arial"/>
-              </a:rPr>
-              <a:t>Reserved for</a:t>
-            </a:r>
-            <a:br/>
-            <a:r>
-              <a:t>speaker video</a:t>
-            </a:r>
-          </a:p>
-        </p:txBody>
-      </p:sp>
     </p:spTree>
     <p:extLst>
       <p:ext uri="{BB962C8B-B14F-4D97-AF65-F5344CB8AC3E}">
@@ -13539,90 +12880,6 @@
           </a:p>
         </p:txBody>
       </p:sp>
-      <p:sp>
-        <p:nvSpPr>
-          <p:cNvPr id="33" name="Rectangle 32"/>
-          <p:cNvSpPr/>
-          <p:nvPr/>
-        </p:nvSpPr>
-        <p:spPr>
-          <a:xfrm>
-            <a:off x="9189720" y="5010912"/>
-            <a:ext cx="2423160" cy="1353312"/>
-          </a:xfrm>
-          <a:prstGeom prst="rect">
-            <a:avLst/>
-          </a:prstGeom>
-          <a:noFill/>
-          <a:ln>
-            <a:solidFill>
-              <a:srgbClr val="D0D4DA"/>
-            </a:solidFill>
-            <a:prstDash val="dash"/>
-          </a:ln>
-        </p:spPr>
-        <p:style>
-          <a:lnRef idx="1">
-            <a:schemeClr val="accent1"/>
-          </a:lnRef>
-          <a:fillRef idx="3">
-            <a:schemeClr val="accent1"/>
-          </a:fillRef>
-          <a:effectRef idx="2">
-            <a:schemeClr val="accent1"/>
-          </a:effectRef>
-          <a:fontRef idx="minor">
-            <a:schemeClr val="lt1"/>
-          </a:fontRef>
-        </p:style>
-        <p:txBody>
-          <a:bodyPr rtlCol="0" anchor="ctr"/>
-          <a:lstStyle/>
-          <a:p>
-            <a:pPr algn="ctr"/>
-            <a:endParaRPr/>
-          </a:p>
-        </p:txBody>
-      </p:sp>
-      <p:sp>
-        <p:nvSpPr>
-          <p:cNvPr id="34" name="TextBox 33"/>
-          <p:cNvSpPr txBox="1"/>
-          <p:nvPr/>
-        </p:nvSpPr>
-        <p:spPr>
-          <a:xfrm>
-            <a:off x="9418320" y="5404104"/>
-            <a:ext cx="1965960" cy="438912"/>
-          </a:xfrm>
-          <a:prstGeom prst="rect">
-            <a:avLst/>
-          </a:prstGeom>
-          <a:noFill/>
-        </p:spPr>
-        <p:txBody>
-          <a:bodyPr wrap="square" anchor="ctr">
-            <a:spAutoFit/>
-          </a:bodyPr>
-          <a:lstStyle/>
-          <a:p>
-            <a:pPr algn="ctr"/>
-            <a:r>
-              <a:rPr sz="1050" b="0">
-                <a:solidFill>
-                  <a:srgbClr val="6B7280"/>
-                </a:solidFill>
-                <a:latin typeface="Arial"/>
-              </a:rPr>
-              <a:t>Reserved for</a:t>
-            </a:r>
-            <a:br/>
-            <a:r>
-              <a:t>speaker video</a:t>
-            </a:r>
-          </a:p>
-        </p:txBody>
-      </p:sp>
     </p:spTree>
     <p:extLst>
       <p:ext uri="{BB962C8B-B14F-4D97-AF65-F5344CB8AC3E}">
@@ -17162,89 +16419,6 @@
           </a:p>
         </p:txBody>
       </p:sp>
-      <p:sp>
-        <p:nvSpPr>
-          <p:cNvPr id="90" name="Rectangle 89"/>
-          <p:cNvSpPr/>
-          <p:nvPr/>
-        </p:nvSpPr>
-        <p:spPr>
-          <a:xfrm>
-            <a:off x="9162288" y="5010912"/>
-            <a:ext cx="2441448" cy="1353312"/>
-          </a:xfrm>
-          <a:prstGeom prst="rect">
-            <a:avLst/>
-          </a:prstGeom>
-          <a:noFill/>
-          <a:ln>
-            <a:solidFill>
-              <a:srgbClr val="D6DADF"/>
-            </a:solidFill>
-          </a:ln>
-        </p:spPr>
-        <p:style>
-          <a:lnRef idx="1">
-            <a:schemeClr val="accent1"/>
-          </a:lnRef>
-          <a:fillRef idx="3">
-            <a:schemeClr val="accent1"/>
-          </a:fillRef>
-          <a:effectRef idx="2">
-            <a:schemeClr val="accent1"/>
-          </a:effectRef>
-          <a:fontRef idx="minor">
-            <a:schemeClr val="lt1"/>
-          </a:fontRef>
-        </p:style>
-        <p:txBody>
-          <a:bodyPr rtlCol="0" anchor="ctr"/>
-          <a:lstStyle/>
-          <a:p>
-            <a:pPr algn="ctr"/>
-            <a:endParaRPr/>
-          </a:p>
-        </p:txBody>
-      </p:sp>
-      <p:sp>
-        <p:nvSpPr>
-          <p:cNvPr id="91" name="TextBox 90"/>
-          <p:cNvSpPr txBox="1"/>
-          <p:nvPr/>
-        </p:nvSpPr>
-        <p:spPr>
-          <a:xfrm>
-            <a:off x="9400032" y="5394960"/>
-            <a:ext cx="1965960" cy="420624"/>
-          </a:xfrm>
-          <a:prstGeom prst="rect">
-            <a:avLst/>
-          </a:prstGeom>
-          <a:noFill/>
-        </p:spPr>
-        <p:txBody>
-          <a:bodyPr wrap="square" anchor="ctr">
-            <a:spAutoFit/>
-          </a:bodyPr>
-          <a:lstStyle/>
-          <a:p>
-            <a:pPr algn="ctr"/>
-            <a:r>
-              <a:rPr sz="1030" b="0">
-                <a:solidFill>
-                  <a:srgbClr val="676D75"/>
-                </a:solidFill>
-                <a:latin typeface="Arial"/>
-              </a:rPr>
-              <a:t>Reserved for</a:t>
-            </a:r>
-            <a:br/>
-            <a:r>
-              <a:t>speaker video</a:t>
-            </a:r>
-          </a:p>
-        </p:txBody>
-      </p:sp>
     </p:spTree>
     <p:extLst>
       <p:ext uri="{BB962C8B-B14F-4D97-AF65-F5344CB8AC3E}">
@@ -19142,89 +18316,6 @@
       </p:sp>
       <p:sp>
         <p:nvSpPr>
-          <p:cNvPr id="49" name="Rectangle 48"/>
-          <p:cNvSpPr/>
-          <p:nvPr/>
-        </p:nvSpPr>
-        <p:spPr>
-          <a:xfrm>
-            <a:off x="9253728" y="4892040"/>
-            <a:ext cx="2331720" cy="1417320"/>
-          </a:xfrm>
-          <a:prstGeom prst="rect">
-            <a:avLst/>
-          </a:prstGeom>
-          <a:noFill/>
-          <a:ln>
-            <a:solidFill>
-              <a:srgbClr val="D6DADF"/>
-            </a:solidFill>
-          </a:ln>
-        </p:spPr>
-        <p:style>
-          <a:lnRef idx="1">
-            <a:schemeClr val="accent1"/>
-          </a:lnRef>
-          <a:fillRef idx="3">
-            <a:schemeClr val="accent1"/>
-          </a:fillRef>
-          <a:effectRef idx="2">
-            <a:schemeClr val="accent1"/>
-          </a:effectRef>
-          <a:fontRef idx="minor">
-            <a:schemeClr val="lt1"/>
-          </a:fontRef>
-        </p:style>
-        <p:txBody>
-          <a:bodyPr rtlCol="0" anchor="ctr"/>
-          <a:lstStyle/>
-          <a:p>
-            <a:pPr algn="ctr"/>
-            <a:endParaRPr/>
-          </a:p>
-        </p:txBody>
-      </p:sp>
-      <p:sp>
-        <p:nvSpPr>
-          <p:cNvPr id="50" name="TextBox 49"/>
-          <p:cNvSpPr txBox="1"/>
-          <p:nvPr/>
-        </p:nvSpPr>
-        <p:spPr>
-          <a:xfrm>
-            <a:off x="9473184" y="5312664"/>
-            <a:ext cx="1874519" cy="438912"/>
-          </a:xfrm>
-          <a:prstGeom prst="rect">
-            <a:avLst/>
-          </a:prstGeom>
-          <a:noFill/>
-        </p:spPr>
-        <p:txBody>
-          <a:bodyPr wrap="square" anchor="ctr">
-            <a:spAutoFit/>
-          </a:bodyPr>
-          <a:lstStyle/>
-          <a:p>
-            <a:pPr algn="ctr"/>
-            <a:r>
-              <a:rPr sz="1019" b="0">
-                <a:solidFill>
-                  <a:srgbClr val="676D75"/>
-                </a:solidFill>
-                <a:latin typeface="Arial"/>
-              </a:rPr>
-              <a:t>Reserved for</a:t>
-            </a:r>
-            <a:br/>
-            <a:r>
-              <a:t>speaker video</a:t>
-            </a:r>
-          </a:p>
-        </p:txBody>
-      </p:sp>
-      <p:sp>
-        <p:nvSpPr>
           <p:cNvPr id="51" name="Rounded Rectangle 50"/>
           <p:cNvSpPr/>
           <p:nvPr/>
@@ -20321,89 +19412,6 @@
                 <a:latin typeface="Arial"/>
               </a:rPr>
               <a:t>.</a:t>
-            </a:r>
-          </a:p>
-        </p:txBody>
-      </p:sp>
-      <p:sp>
-        <p:nvSpPr>
-          <p:cNvPr id="25" name="Rectangle 24"/>
-          <p:cNvSpPr/>
-          <p:nvPr/>
-        </p:nvSpPr>
-        <p:spPr>
-          <a:xfrm>
-            <a:off x="9464040" y="4828032"/>
-            <a:ext cx="2148840" cy="1417320"/>
-          </a:xfrm>
-          <a:prstGeom prst="rect">
-            <a:avLst/>
-          </a:prstGeom>
-          <a:noFill/>
-          <a:ln>
-            <a:solidFill>
-              <a:srgbClr val="D6DADF"/>
-            </a:solidFill>
-          </a:ln>
-        </p:spPr>
-        <p:style>
-          <a:lnRef idx="1">
-            <a:schemeClr val="accent1"/>
-          </a:lnRef>
-          <a:fillRef idx="3">
-            <a:schemeClr val="accent1"/>
-          </a:fillRef>
-          <a:effectRef idx="2">
-            <a:schemeClr val="accent1"/>
-          </a:effectRef>
-          <a:fontRef idx="minor">
-            <a:schemeClr val="lt1"/>
-          </a:fontRef>
-        </p:style>
-        <p:txBody>
-          <a:bodyPr rtlCol="0" anchor="ctr"/>
-          <a:lstStyle/>
-          <a:p>
-            <a:pPr algn="ctr"/>
-            <a:endParaRPr/>
-          </a:p>
-        </p:txBody>
-      </p:sp>
-      <p:sp>
-        <p:nvSpPr>
-          <p:cNvPr id="26" name="TextBox 25"/>
-          <p:cNvSpPr txBox="1"/>
-          <p:nvPr/>
-        </p:nvSpPr>
-        <p:spPr>
-          <a:xfrm>
-            <a:off x="9674352" y="5239512"/>
-            <a:ext cx="1737360" cy="438912"/>
-          </a:xfrm>
-          <a:prstGeom prst="rect">
-            <a:avLst/>
-          </a:prstGeom>
-          <a:noFill/>
-        </p:spPr>
-        <p:txBody>
-          <a:bodyPr wrap="square" anchor="ctr">
-            <a:spAutoFit/>
-          </a:bodyPr>
-          <a:lstStyle/>
-          <a:p>
-            <a:pPr algn="ctr"/>
-            <a:r>
-              <a:rPr sz="1000" b="0">
-                <a:solidFill>
-                  <a:srgbClr val="676D75"/>
-                </a:solidFill>
-                <a:latin typeface="Arial"/>
-              </a:rPr>
-              <a:t>Reserved for</a:t>
-            </a:r>
-            <a:br/>
-            <a:r>
-              <a:t>speaker video</a:t>
             </a:r>
           </a:p>
         </p:txBody>

</xml_diff>